<commit_message>
docs: regenerate presentation to integrate virtual fence static preview and discord video alert
</commit_message>
<xml_diff>
--- a/AIoT_Safety_Platform_Report.pptx
+++ b/AIoT_Safety_Platform_Report.pptx
@@ -13,6 +13,8 @@
     <p:sldId id="261" r:id="rId12"/>
     <p:sldId id="262" r:id="rId13"/>
     <p:sldId id="263" r:id="rId14"/>
+    <p:sldId id="264" r:id="rId15"/>
+    <p:sldId id="265" r:id="rId16"/>
   </p:sldIdLst>
   <p:sldSz cx="12188952" cy="6858000" type="screen4x3"/>
   <p:notesSz cx="6858000" cy="9144000"/>
@@ -3222,6 +3224,84 @@
 </p:sld>
 </file>
 
+<file path=ppt/slides/slide10.xml><?xml version="1.0" encoding="utf-8"?>
+<p:sld xmlns:a="http://schemas.openxmlformats.org/drawingml/2006/main" xmlns:p="http://schemas.openxmlformats.org/presentationml/2006/main" xmlns:r="http://schemas.openxmlformats.org/officeDocument/2006/relationships">
+  <p:cSld>
+    <p:bg>
+      <p:bgPr>
+        <a:solidFill>
+          <a:srgbClr val="0F172A"/>
+        </a:solidFill>
+        <a:effectLst/>
+      </p:bgPr>
+    </p:bg>
+    <p:spTree>
+      <p:nvGrpSpPr>
+        <p:cNvPr id="1" name=""/>
+        <p:cNvGrpSpPr/>
+        <p:nvPr/>
+      </p:nvGrpSpPr>
+      <p:grpSpPr/>
+      <p:sp>
+        <p:nvSpPr>
+          <p:cNvPr id="2" name="TextBox 1"/>
+          <p:cNvSpPr txBox="1"/>
+          <p:nvPr/>
+        </p:nvSpPr>
+        <p:spPr>
+          <a:xfrm>
+            <a:off x="1371600" y="2011680"/>
+            <a:ext cx="9445752" cy="3200400"/>
+          </a:xfrm>
+          <a:prstGeom prst="rect">
+            <a:avLst/>
+          </a:prstGeom>
+          <a:noFill/>
+        </p:spPr>
+        <p:txBody>
+          <a:bodyPr wrap="square" lIns="0" tIns="0">
+            <a:spAutoFit/>
+          </a:bodyPr>
+          <a:lstStyle/>
+          <a:p>
+            <a:pPr algn="ctr">
+              <a:spcAft>
+                <a:spcPts val="2000"/>
+              </a:spcAft>
+              <a:defRPr sz="4000" b="1">
+                <a:solidFill>
+                  <a:srgbClr val="FFFFFF"/>
+                </a:solidFill>
+                <a:latin typeface="Microsoft JhengHei"/>
+              </a:defRPr>
+            </a:pPr>
+            <a:r>
+              <a:t>簡報結束，謝謝聆聽</a:t>
+            </a:r>
+          </a:p>
+          <a:p>
+            <a:pPr algn="ctr">
+              <a:defRPr sz="1800">
+                <a:solidFill>
+                  <a:srgbClr val="94A3B8"/>
+                </a:solidFill>
+                <a:latin typeface="Microsoft JhengHei"/>
+              </a:defRPr>
+            </a:pPr>
+            <a:r>
+              <a:t>AIoT 智慧安全監控與主動防禦平台</a:t>
+            </a:r>
+          </a:p>
+        </p:txBody>
+      </p:sp>
+    </p:spTree>
+  </p:cSld>
+  <p:clrMapOvr>
+    <a:masterClrMapping/>
+  </p:clrMapOvr>
+</p:sld>
+</file>
+
 <file path=ppt/slides/slide2.xml><?xml version="1.0" encoding="utf-8"?>
 <p:sld xmlns:a="http://schemas.openxmlformats.org/drawingml/2006/main" xmlns:p="http://schemas.openxmlformats.org/presentationml/2006/main" xmlns:r="http://schemas.openxmlformats.org/officeDocument/2006/relationships">
   <p:cSld>
@@ -3926,7 +4006,7 @@
               </a:defRPr>
             </a:pPr>
             <a:r>
-              <a:t>🚨 Discord 即時警報</a:t>
+              <a:t>🚨 Discord 雙階即時警報</a:t>
             </a:r>
           </a:p>
           <a:p>
@@ -3945,7 +4025,7 @@
               </a:defRPr>
             </a:pPr>
             <a:r>
-              <a:t>• 即時警報發送：偵測到安全違規行為時，自動調用 Webhook，將警告文字訊息即時發送至 Discord 頻道。</a:t>
+              <a:t>• 雙階段警報機制：違規當下立即發送警告文字與畫面截圖；影片預錄完成後，自動非同步推送回放影片至 Discord。</a:t>
             </a:r>
           </a:p>
           <a:p>
@@ -3964,7 +4044,7 @@
               </a:defRPr>
             </a:pPr>
             <a:r>
-              <a:t>• 違規畫面截圖：自動擷取當下違規畫面的圖片作為附件一併發送，提供管理人員明確的第一手事證。</a:t>
+              <a:t>• 違規影片事證：直接在 Discord 接收 10 秒違規影片檔，省去開啟網頁系統的時間，提供主管第一手影像事證。</a:t>
             </a:r>
           </a:p>
           <a:p>
@@ -4595,7 +4675,7 @@
               </a:defRPr>
             </a:pPr>
             <a:r>
-              <a:t>• Discord Webhook 警報：負責向外部 Discord 頻道發送包含即時違規影像截圖的訊息通知，落實主動警報。</a:t>
+              <a:t>• Discord Webhook 警報：負責向外部 Discord 頻道發送包含即時違規影像截圖的訊息通知，並於影片上傳後自動推送影片回放。</a:t>
             </a:r>
           </a:p>
         </p:txBody>
@@ -5491,7 +5571,7 @@
               </a:defRPr>
             </a:pPr>
             <a:r>
-              <a:t>Discord Webhook</a:t>
+              <a:t>雙階 Discord 通報</a:t>
             </a:r>
           </a:p>
           <a:p>
@@ -5510,7 +5590,7 @@
               </a:defRPr>
             </a:pPr>
             <a:r>
-              <a:t>• 自動呼叫 Webhook 將警報文字及違規照片傳送至 Discord</a:t>
+              <a:t>• 階段一：實時發送警報文字與現場截圖至 Discord</a:t>
             </a:r>
           </a:p>
           <a:p>
@@ -5529,7 +5609,7 @@
               </a:defRPr>
             </a:pPr>
             <a:r>
-              <a:t>• 內建 10 秒去抖動冷卻時間，防止洗版</a:t>
+              <a:t>• 階段二：5 秒後前端合成預錄影片上傳，後端非同步推送影片</a:t>
             </a:r>
           </a:p>
         </p:txBody>
@@ -6021,7 +6101,7 @@
               </a:defRPr>
             </a:pPr>
             <a:r>
-              <a:t>06  總結與未來展望</a:t>
+              <a:t>06  違規前後預錄與歷史回溯</a:t>
             </a:r>
           </a:p>
         </p:txBody>
@@ -6035,147 +6115,6 @@
         <p:spPr>
           <a:xfrm>
             <a:off x="731520" y="1463040"/>
-            <a:ext cx="5120640" cy="4572000"/>
-          </a:xfrm>
-          <a:prstGeom prst="roundRect">
-            <a:avLst/>
-          </a:prstGeom>
-          <a:solidFill>
-            <a:srgbClr val="FFFFFF"/>
-          </a:solidFill>
-          <a:ln w="19050">
-            <a:solidFill>
-              <a:srgbClr val="10B981"/>
-            </a:solidFill>
-          </a:ln>
-        </p:spPr>
-        <p:style>
-          <a:lnRef idx="1">
-            <a:schemeClr val="accent1"/>
-          </a:lnRef>
-          <a:fillRef idx="3">
-            <a:schemeClr val="accent1"/>
-          </a:fillRef>
-          <a:effectRef idx="2">
-            <a:schemeClr val="accent1"/>
-          </a:effectRef>
-          <a:fontRef idx="minor">
-            <a:schemeClr val="lt1"/>
-          </a:fontRef>
-        </p:style>
-        <p:txBody>
-          <a:bodyPr rtlCol="0" anchor="ctr"/>
-          <a:lstStyle/>
-          <a:p>
-            <a:pPr algn="ctr"/>
-          </a:p>
-        </p:txBody>
-      </p:sp>
-      <p:sp>
-        <p:nvSpPr>
-          <p:cNvPr id="5" name="TextBox 4"/>
-          <p:cNvSpPr txBox="1"/>
-          <p:nvPr/>
-        </p:nvSpPr>
-        <p:spPr>
-          <a:xfrm>
-            <a:off x="1005840" y="1737360"/>
-            <a:ext cx="4572000" cy="4023360"/>
-          </a:xfrm>
-          <a:prstGeom prst="rect">
-            <a:avLst/>
-          </a:prstGeom>
-          <a:noFill/>
-        </p:spPr>
-        <p:txBody>
-          <a:bodyPr wrap="square" tIns="91440" bIns="91440">
-            <a:spAutoFit/>
-          </a:bodyPr>
-          <a:lstStyle/>
-          <a:p>
-            <a:pPr>
-              <a:spcAft>
-                <a:spcPts val="1000"/>
-              </a:spcAft>
-              <a:defRPr sz="2000" b="1">
-                <a:solidFill>
-                  <a:srgbClr val="0F172A"/>
-                </a:solidFill>
-                <a:latin typeface="Microsoft JhengHei"/>
-              </a:defRPr>
-            </a:pPr>
-            <a:r>
-              <a:t>🏆 系統實施成效</a:t>
-            </a:r>
-          </a:p>
-          <a:p>
-            <a:pPr>
-              <a:lnSpc>
-                <a:spcPct val="115000"/>
-              </a:lnSpc>
-              <a:spcAft>
-                <a:spcPts val="600"/>
-              </a:spcAft>
-              <a:defRPr sz="1500">
-                <a:solidFill>
-                  <a:srgbClr val="0F172A"/>
-                </a:solidFill>
-                <a:latin typeface="Microsoft JhengHei"/>
-              </a:defRPr>
-            </a:pPr>
-            <a:r>
-              <a:t>• 被動防護轉為主動防禦：跳脫傳統事後調閱監視器的模式，在違規發生的第一秒立即通報，將意外機率降至最低。</a:t>
-            </a:r>
-          </a:p>
-          <a:p>
-            <a:pPr>
-              <a:lnSpc>
-                <a:spcPct val="115000"/>
-              </a:lnSpc>
-              <a:spcAft>
-                <a:spcPts val="600"/>
-              </a:spcAft>
-              <a:defRPr sz="1500">
-                <a:solidFill>
-                  <a:srgbClr val="0F172A"/>
-                </a:solidFill>
-                <a:latin typeface="Microsoft JhengHei"/>
-              </a:defRPr>
-            </a:pPr>
-            <a:r>
-              <a:t>• 工安管理數位化：結合資料庫與 AI 分析，將冰冷的監控影像轉化為具備管理價值的工安稽核報告。</a:t>
-            </a:r>
-          </a:p>
-          <a:p>
-            <a:pPr>
-              <a:lnSpc>
-                <a:spcPct val="115000"/>
-              </a:lnSpc>
-              <a:spcAft>
-                <a:spcPts val="600"/>
-              </a:spcAft>
-              <a:defRPr sz="1500">
-                <a:solidFill>
-                  <a:srgbClr val="0F172A"/>
-                </a:solidFill>
-                <a:latin typeface="Microsoft JhengHei"/>
-              </a:defRPr>
-            </a:pPr>
-            <a:r>
-              <a:t>• 顯著降低巡檢人力：全天候自動化監控，減輕安全稽核人員現場巡查負擔，提升管理效率。</a:t>
-            </a:r>
-          </a:p>
-        </p:txBody>
-      </p:sp>
-      <p:sp>
-        <p:nvSpPr>
-          <p:cNvPr id="6" name="Rounded Rectangle 5"/>
-          <p:cNvSpPr/>
-          <p:nvPr/>
-        </p:nvSpPr>
-        <p:spPr>
-          <a:xfrm>
-            <a:off x="6309360" y="1463040"/>
             <a:ext cx="5120640" cy="4572000"/>
           </a:xfrm>
           <a:prstGeom prst="roundRect">
@@ -6214,13 +6153,13 @@
       </p:sp>
       <p:sp>
         <p:nvSpPr>
-          <p:cNvPr id="7" name="TextBox 6"/>
+          <p:cNvPr id="5" name="TextBox 4"/>
           <p:cNvSpPr txBox="1"/>
           <p:nvPr/>
         </p:nvSpPr>
         <p:spPr>
           <a:xfrm>
-            <a:off x="6583680" y="1737360"/>
+            <a:off x="1005840" y="1737360"/>
             <a:ext cx="4572000" cy="4023360"/>
           </a:xfrm>
           <a:prstGeom prst="rect">
@@ -6246,7 +6185,7 @@
               </a:defRPr>
             </a:pPr>
             <a:r>
-              <a:t>🚀 未來擴充方向</a:t>
+              <a:t>前端 Canvas 雙向預錄</a:t>
             </a:r>
           </a:p>
           <a:p>
@@ -6265,7 +6204,7 @@
               </a:defRPr>
             </a:pPr>
             <a:r>
-              <a:t>• 擴充更多防護具識別：未來計劃引入安全鞋、防墜安全帶、護目鏡或口罩等多種類別的 YOLO 偵測模型。</a:t>
+              <a:t>• HTML5 Canvas 錄製：前端利用 `MediaRecorder` API 監聽 `captureStream(10)`，實現零伺服器效能開銷的錄影。</a:t>
             </a:r>
           </a:p>
           <a:p>
@@ -6284,7 +6223,7 @@
               </a:defRPr>
             </a:pPr>
             <a:r>
-              <a:t>• 多相機與多廠區支援：支援接入多路 IP Camera，實現大規模廠區或跨廠區的同步邊緣監控與集中管理。</a:t>
+              <a:t>• 5+5 雙向預錄機制：前端隨時維持 5 秒的環形預錄緩衝區；當違規觸發時，繼續錄製 5 秒，隨後合併上傳。</a:t>
             </a:r>
           </a:p>
           <a:p>
@@ -6303,7 +6242,148 @@
               </a:defRPr>
             </a:pPr>
             <a:r>
-              <a:t>• 雙平台通報機制：除目前已實現的 Discord 通報外，未來可啟用並完善 LINE Notify 通報，滿足多元通訊需求。</a:t>
+              <a:t>• 保留 YOLO 偵測框線：直接錄製前端 Canvas 畫面，使得回放影片中可完整保留 YOLO 的紅色違規框標籤。</a:t>
+            </a:r>
+          </a:p>
+        </p:txBody>
+      </p:sp>
+      <p:sp>
+        <p:nvSpPr>
+          <p:cNvPr id="6" name="Rounded Rectangle 5"/>
+          <p:cNvSpPr/>
+          <p:nvPr/>
+        </p:nvSpPr>
+        <p:spPr>
+          <a:xfrm>
+            <a:off x="6309360" y="1463040"/>
+            <a:ext cx="5120640" cy="4572000"/>
+          </a:xfrm>
+          <a:prstGeom prst="roundRect">
+            <a:avLst/>
+          </a:prstGeom>
+          <a:solidFill>
+            <a:srgbClr val="FFFFFF"/>
+          </a:solidFill>
+          <a:ln w="19050">
+            <a:solidFill>
+              <a:srgbClr val="2563EB"/>
+            </a:solidFill>
+          </a:ln>
+        </p:spPr>
+        <p:style>
+          <a:lnRef idx="1">
+            <a:schemeClr val="accent1"/>
+          </a:lnRef>
+          <a:fillRef idx="3">
+            <a:schemeClr val="accent1"/>
+          </a:fillRef>
+          <a:effectRef idx="2">
+            <a:schemeClr val="accent1"/>
+          </a:effectRef>
+          <a:fontRef idx="minor">
+            <a:schemeClr val="lt1"/>
+          </a:fontRef>
+        </p:style>
+        <p:txBody>
+          <a:bodyPr rtlCol="0" anchor="ctr"/>
+          <a:lstStyle/>
+          <a:p>
+            <a:pPr algn="ctr"/>
+          </a:p>
+        </p:txBody>
+      </p:sp>
+      <p:sp>
+        <p:nvSpPr>
+          <p:cNvPr id="7" name="TextBox 6"/>
+          <p:cNvSpPr txBox="1"/>
+          <p:nvPr/>
+        </p:nvSpPr>
+        <p:spPr>
+          <a:xfrm>
+            <a:off x="6583680" y="1737360"/>
+            <a:ext cx="4572000" cy="4023360"/>
+          </a:xfrm>
+          <a:prstGeom prst="rect">
+            <a:avLst/>
+          </a:prstGeom>
+          <a:noFill/>
+        </p:spPr>
+        <p:txBody>
+          <a:bodyPr wrap="square" tIns="91440" bIns="91440">
+            <a:spAutoFit/>
+          </a:bodyPr>
+          <a:lstStyle/>
+          <a:p>
+            <a:pPr>
+              <a:spcAft>
+                <a:spcPts val="1000"/>
+              </a:spcAft>
+              <a:defRPr sz="2000" b="1">
+                <a:solidFill>
+                  <a:srgbClr val="0F172A"/>
+                </a:solidFill>
+                <a:latin typeface="Microsoft JhengHei"/>
+              </a:defRPr>
+            </a:pPr>
+            <a:r>
+              <a:t>後端影片關聯與 Modal 播放</a:t>
+            </a:r>
+          </a:p>
+          <a:p>
+            <a:pPr>
+              <a:lnSpc>
+                <a:spcPct val="115000"/>
+              </a:lnSpc>
+              <a:spcAft>
+                <a:spcPts val="600"/>
+              </a:spcAft>
+              <a:defRPr sz="1500">
+                <a:solidFill>
+                  <a:srgbClr val="0F172A"/>
+                </a:solidFill>
+                <a:latin typeface="Microsoft JhengHei"/>
+              </a:defRPr>
+            </a:pPr>
+            <a:r>
+              <a:t>• 後端二進位儲存：API 接收二進位影片後，將影片寫入 `public/videos/`，並自動更新資料庫的 `videoPath` 欄位。</a:t>
+            </a:r>
+          </a:p>
+          <a:p>
+            <a:pPr>
+              <a:lnSpc>
+                <a:spcPct val="115000"/>
+              </a:lnSpc>
+              <a:spcAft>
+                <a:spcPts val="600"/>
+              </a:spcAft>
+              <a:defRPr sz="1500">
+                <a:solidFill>
+                  <a:srgbClr val="0F172A"/>
+                </a:solidFill>
+                <a:latin typeface="Microsoft JhengHei"/>
+              </a:defRPr>
+            </a:pPr>
+            <a:r>
+              <a:t>• 動態回放按鈕：影片上傳後，後端透過 Socket.io 廣播 `video_ready`，前端日誌列表將動態出現「🎥 回放」按鈕。</a:t>
+            </a:r>
+          </a:p>
+          <a:p>
+            <a:pPr>
+              <a:lnSpc>
+                <a:spcPct val="115000"/>
+              </a:lnSpc>
+              <a:spcAft>
+                <a:spcPts val="600"/>
+              </a:spcAft>
+              <a:defRPr sz="1500">
+                <a:solidFill>
+                  <a:srgbClr val="0F172A"/>
+                </a:solidFill>
+                <a:latin typeface="Microsoft JhengHei"/>
+              </a:defRPr>
+            </a:pPr>
+            <a:r>
+              <a:t>• 彈出式質感播放器：點擊播放按鈕，在畫面上跳出精美的半透明磨砂玻璃質感 Modal，並流暢播放 WebM 影片。</a:t>
             </a:r>
           </a:p>
         </p:txBody>
@@ -6322,7 +6402,7 @@
     <p:bg>
       <p:bgPr>
         <a:solidFill>
-          <a:srgbClr val="0F172A"/>
+          <a:srgbClr val="F8FAFC"/>
         </a:solidFill>
         <a:effectLst/>
       </p:bgPr>
@@ -6336,14 +6416,57 @@
       <p:grpSpPr/>
       <p:sp>
         <p:nvSpPr>
-          <p:cNvPr id="2" name="TextBox 1"/>
+          <p:cNvPr id="2" name="Rectangle 1"/>
+          <p:cNvSpPr/>
+          <p:nvPr/>
+        </p:nvSpPr>
+        <p:spPr>
+          <a:xfrm>
+            <a:off x="731520" y="548640"/>
+            <a:ext cx="137160" cy="548640"/>
+          </a:xfrm>
+          <a:prstGeom prst="rect">
+            <a:avLst/>
+          </a:prstGeom>
+          <a:solidFill>
+            <a:srgbClr val="2563EB"/>
+          </a:solidFill>
+          <a:ln>
+            <a:noFill/>
+          </a:ln>
+        </p:spPr>
+        <p:style>
+          <a:lnRef idx="1">
+            <a:schemeClr val="accent1"/>
+          </a:lnRef>
+          <a:fillRef idx="3">
+            <a:schemeClr val="accent1"/>
+          </a:fillRef>
+          <a:effectRef idx="2">
+            <a:schemeClr val="accent1"/>
+          </a:effectRef>
+          <a:fontRef idx="minor">
+            <a:schemeClr val="lt1"/>
+          </a:fontRef>
+        </p:style>
+        <p:txBody>
+          <a:bodyPr rtlCol="0" anchor="ctr"/>
+          <a:lstStyle/>
+          <a:p>
+            <a:pPr algn="ctr"/>
+          </a:p>
+        </p:txBody>
+      </p:sp>
+      <p:sp>
+        <p:nvSpPr>
+          <p:cNvPr id="3" name="TextBox 2"/>
           <p:cNvSpPr txBox="1"/>
           <p:nvPr/>
         </p:nvSpPr>
         <p:spPr>
           <a:xfrm>
-            <a:off x="1371600" y="2011680"/>
-            <a:ext cx="9445752" cy="3200400"/>
+            <a:off x="1005840" y="457200"/>
+            <a:ext cx="10058400" cy="731520"/>
           </a:xfrm>
           <a:prstGeom prst="rect">
             <a:avLst/>
@@ -6351,37 +6474,690 @@
           <a:noFill/>
         </p:spPr>
         <p:txBody>
-          <a:bodyPr wrap="square" lIns="0" tIns="0">
+          <a:bodyPr wrap="square" lIns="0" tIns="0" rIns="0" bIns="0">
             <a:spAutoFit/>
           </a:bodyPr>
           <a:lstStyle/>
           <a:p>
-            <a:pPr algn="ctr">
-              <a:spcAft>
-                <a:spcPts val="2000"/>
-              </a:spcAft>
-              <a:defRPr sz="4000" b="1">
-                <a:solidFill>
-                  <a:srgbClr val="FFFFFF"/>
-                </a:solidFill>
-                <a:latin typeface="Microsoft JhengHei"/>
-              </a:defRPr>
-            </a:pPr>
-            <a:r>
-              <a:t>簡報結束，謝謝聆聽</a:t>
-            </a:r>
-          </a:p>
-          <a:p>
-            <a:pPr algn="ctr">
-              <a:defRPr sz="1800">
-                <a:solidFill>
-                  <a:srgbClr val="94A3B8"/>
-                </a:solidFill>
-                <a:latin typeface="Microsoft JhengHei"/>
-              </a:defRPr>
-            </a:pPr>
-            <a:r>
-              <a:t>AIoT 智慧安全監控與主動防禦平台</a:t>
+            <a:pPr>
+              <a:defRPr sz="2600" b="1">
+                <a:solidFill>
+                  <a:srgbClr val="0F172A"/>
+                </a:solidFill>
+                <a:latin typeface="Microsoft JhengHei"/>
+              </a:defRPr>
+            </a:pPr>
+            <a:r>
+              <a:t>07  系統人性化互動設計</a:t>
+            </a:r>
+          </a:p>
+        </p:txBody>
+      </p:sp>
+      <p:sp>
+        <p:nvSpPr>
+          <p:cNvPr id="4" name="Rounded Rectangle 3"/>
+          <p:cNvSpPr/>
+          <p:nvPr/>
+        </p:nvSpPr>
+        <p:spPr>
+          <a:xfrm>
+            <a:off x="731520" y="1463040"/>
+            <a:ext cx="5120640" cy="4572000"/>
+          </a:xfrm>
+          <a:prstGeom prst="roundRect">
+            <a:avLst/>
+          </a:prstGeom>
+          <a:solidFill>
+            <a:srgbClr val="FFFFFF"/>
+          </a:solidFill>
+          <a:ln w="19050">
+            <a:solidFill>
+              <a:srgbClr val="EF4444"/>
+            </a:solidFill>
+          </a:ln>
+        </p:spPr>
+        <p:style>
+          <a:lnRef idx="1">
+            <a:schemeClr val="accent1"/>
+          </a:lnRef>
+          <a:fillRef idx="3">
+            <a:schemeClr val="accent1"/>
+          </a:fillRef>
+          <a:effectRef idx="2">
+            <a:schemeClr val="accent1"/>
+          </a:effectRef>
+          <a:fontRef idx="minor">
+            <a:schemeClr val="lt1"/>
+          </a:fontRef>
+        </p:style>
+        <p:txBody>
+          <a:bodyPr rtlCol="0" anchor="ctr"/>
+          <a:lstStyle/>
+          <a:p>
+            <a:pPr algn="ctr"/>
+          </a:p>
+        </p:txBody>
+      </p:sp>
+      <p:sp>
+        <p:nvSpPr>
+          <p:cNvPr id="5" name="TextBox 4"/>
+          <p:cNvSpPr txBox="1"/>
+          <p:nvPr/>
+        </p:nvSpPr>
+        <p:spPr>
+          <a:xfrm>
+            <a:off x="1005840" y="1737360"/>
+            <a:ext cx="4572000" cy="4023360"/>
+          </a:xfrm>
+          <a:prstGeom prst="rect">
+            <a:avLst/>
+          </a:prstGeom>
+          <a:noFill/>
+        </p:spPr>
+        <p:txBody>
+          <a:bodyPr wrap="square" tIns="91440" bIns="91440">
+            <a:spAutoFit/>
+          </a:bodyPr>
+          <a:lstStyle/>
+          <a:p>
+            <a:pPr>
+              <a:spcAft>
+                <a:spcPts val="1000"/>
+              </a:spcAft>
+              <a:defRPr sz="2000" b="1">
+                <a:solidFill>
+                  <a:srgbClr val="0F172A"/>
+                </a:solidFill>
+                <a:latin typeface="Microsoft JhengHei"/>
+              </a:defRPr>
+            </a:pPr>
+            <a:r>
+              <a:t>📐 電子圍籬與空間判定</a:t>
+            </a:r>
+          </a:p>
+          <a:p>
+            <a:pPr>
+              <a:lnSpc>
+                <a:spcPct val="115000"/>
+              </a:lnSpc>
+              <a:spcAft>
+                <a:spcPts val="600"/>
+              </a:spcAft>
+              <a:defRPr sz="1500">
+                <a:solidFill>
+                  <a:srgbClr val="0F172A"/>
+                </a:solidFill>
+                <a:latin typeface="Microsoft JhengHei"/>
+              </a:defRPr>
+            </a:pPr>
+            <a:r>
+              <a:t>• 多邊形圍籬繪製：使用者點擊 Canvas 即可繪製任意形狀的多邊形管制區，並提供半透明紅色的區域視覺提示。</a:t>
+            </a:r>
+          </a:p>
+          <a:p>
+            <a:pPr>
+              <a:lnSpc>
+                <a:spcPct val="115000"/>
+              </a:lnSpc>
+              <a:spcAft>
+                <a:spcPts val="600"/>
+              </a:spcAft>
+              <a:defRPr sz="1500">
+                <a:solidFill>
+                  <a:srgbClr val="0F172A"/>
+                </a:solidFill>
+                <a:latin typeface="Microsoft JhengHei"/>
+              </a:defRPr>
+            </a:pPr>
+            <a:r>
+              <a:t>• 座標相對比例化：所有頂點座標以 0.0 ~ 1.0 的相對比例儲存，確保在瀏覽器縮放與不同解析度下百分之百精準。</a:t>
+            </a:r>
+          </a:p>
+          <a:p>
+            <a:pPr>
+              <a:lnSpc>
+                <a:spcPct val="115000"/>
+              </a:lnSpc>
+              <a:spcAft>
+                <a:spcPts val="600"/>
+              </a:spcAft>
+              <a:defRPr sz="1500">
+                <a:solidFill>
+                  <a:srgbClr val="0F172A"/>
+                </a:solidFill>
+                <a:latin typeface="Microsoft JhengHei"/>
+              </a:defRPr>
+            </a:pPr>
+            <a:r>
+              <a:t>• Point-in-Polygon 判定：後端在 Node.js 中實作高效的射線法，計算人員底邊中心點，非管制區內的违規將自動過濾。</a:t>
+            </a:r>
+          </a:p>
+        </p:txBody>
+      </p:sp>
+      <p:sp>
+        <p:nvSpPr>
+          <p:cNvPr id="6" name="Rounded Rectangle 5"/>
+          <p:cNvSpPr/>
+          <p:nvPr/>
+        </p:nvSpPr>
+        <p:spPr>
+          <a:xfrm>
+            <a:off x="6309360" y="1463040"/>
+            <a:ext cx="5120640" cy="4572000"/>
+          </a:xfrm>
+          <a:prstGeom prst="roundRect">
+            <a:avLst/>
+          </a:prstGeom>
+          <a:solidFill>
+            <a:srgbClr val="FFFFFF"/>
+          </a:solidFill>
+          <a:ln w="19050">
+            <a:solidFill>
+              <a:srgbClr val="EF4444"/>
+            </a:solidFill>
+          </a:ln>
+        </p:spPr>
+        <p:style>
+          <a:lnRef idx="1">
+            <a:schemeClr val="accent1"/>
+          </a:lnRef>
+          <a:fillRef idx="3">
+            <a:schemeClr val="accent1"/>
+          </a:fillRef>
+          <a:effectRef idx="2">
+            <a:schemeClr val="accent1"/>
+          </a:effectRef>
+          <a:fontRef idx="minor">
+            <a:schemeClr val="lt1"/>
+          </a:fontRef>
+        </p:style>
+        <p:txBody>
+          <a:bodyPr rtlCol="0" anchor="ctr"/>
+          <a:lstStyle/>
+          <a:p>
+            <a:pPr algn="ctr"/>
+          </a:p>
+        </p:txBody>
+      </p:sp>
+      <p:sp>
+        <p:nvSpPr>
+          <p:cNvPr id="7" name="TextBox 6"/>
+          <p:cNvSpPr txBox="1"/>
+          <p:nvPr/>
+        </p:nvSpPr>
+        <p:spPr>
+          <a:xfrm>
+            <a:off x="6583680" y="1737360"/>
+            <a:ext cx="4572000" cy="4023360"/>
+          </a:xfrm>
+          <a:prstGeom prst="rect">
+            <a:avLst/>
+          </a:prstGeom>
+          <a:noFill/>
+        </p:spPr>
+        <p:txBody>
+          <a:bodyPr wrap="square" tIns="91440" bIns="91440">
+            <a:spAutoFit/>
+          </a:bodyPr>
+          <a:lstStyle/>
+          <a:p>
+            <a:pPr>
+              <a:spcAft>
+                <a:spcPts val="1000"/>
+              </a:spcAft>
+              <a:defRPr sz="2000" b="1">
+                <a:solidFill>
+                  <a:srgbClr val="0F172A"/>
+                </a:solidFill>
+                <a:latin typeface="Microsoft JhengHei"/>
+              </a:defRPr>
+            </a:pPr>
+            <a:r>
+              <a:t>⚙️ 人性化交互與防錯設計</a:t>
+            </a:r>
+          </a:p>
+          <a:p>
+            <a:pPr>
+              <a:lnSpc>
+                <a:spcPct val="115000"/>
+              </a:lnSpc>
+              <a:spcAft>
+                <a:spcPts val="600"/>
+              </a:spcAft>
+              <a:defRPr sz="1500">
+                <a:solidFill>
+                  <a:srgbClr val="0F172A"/>
+                </a:solidFill>
+                <a:latin typeface="Microsoft JhengHei"/>
+              </a:defRPr>
+            </a:pPr>
+            <a:r>
+              <a:t>• 無串流靜態編輯與預覽：支援在未啟動相機/IP Cam 時，依然能繪製、清除並載入預設圍籬，提供靜態 Canvas 渲染。</a:t>
+            </a:r>
+          </a:p>
+          <a:p>
+            <a:pPr>
+              <a:lnSpc>
+                <a:spcPct val="115000"/>
+              </a:lnSpc>
+              <a:spcAft>
+                <a:spcPts val="600"/>
+              </a:spcAft>
+              <a:defRPr sz="1500">
+                <a:solidFill>
+                  <a:srgbClr val="0F172A"/>
+                </a:solidFill>
+                <a:latin typeface="Microsoft JhengHei"/>
+              </a:defRPr>
+            </a:pPr>
+            <a:r>
+              <a:t>• 滑鼠穿透控制優化：進入編輯狀態時自動修改為 `pointer-events: auto`，儲存後恢復 `none` 避免干擾按鈕操作。</a:t>
+            </a:r>
+          </a:p>
+          <a:p>
+            <a:pPr>
+              <a:lnSpc>
+                <a:spcPct val="115000"/>
+              </a:lnSpc>
+              <a:spcAft>
+                <a:spcPts val="600"/>
+              </a:spcAft>
+              <a:defRPr sz="1500">
+                <a:solidFill>
+                  <a:srgbClr val="0F172A"/>
+                </a:solidFill>
+                <a:latin typeface="Microsoft JhengHei"/>
+              </a:defRPr>
+            </a:pPr>
+            <a:r>
+              <a:t>• 防禦性座標設計：避免 Canvas 寬高在初始化為 0 時計算出 NaN 座標，增加防錯除錯，保障代碼的健壯度。</a:t>
+            </a:r>
+          </a:p>
+        </p:txBody>
+      </p:sp>
+    </p:spTree>
+  </p:cSld>
+  <p:clrMapOvr>
+    <a:masterClrMapping/>
+  </p:clrMapOvr>
+</p:sld>
+</file>
+
+<file path=ppt/slides/slide9.xml><?xml version="1.0" encoding="utf-8"?>
+<p:sld xmlns:a="http://schemas.openxmlformats.org/drawingml/2006/main" xmlns:p="http://schemas.openxmlformats.org/presentationml/2006/main" xmlns:r="http://schemas.openxmlformats.org/officeDocument/2006/relationships">
+  <p:cSld>
+    <p:bg>
+      <p:bgPr>
+        <a:solidFill>
+          <a:srgbClr val="F8FAFC"/>
+        </a:solidFill>
+        <a:effectLst/>
+      </p:bgPr>
+    </p:bg>
+    <p:spTree>
+      <p:nvGrpSpPr>
+        <p:cNvPr id="1" name=""/>
+        <p:cNvGrpSpPr/>
+        <p:nvPr/>
+      </p:nvGrpSpPr>
+      <p:grpSpPr/>
+      <p:sp>
+        <p:nvSpPr>
+          <p:cNvPr id="2" name="Rectangle 1"/>
+          <p:cNvSpPr/>
+          <p:nvPr/>
+        </p:nvSpPr>
+        <p:spPr>
+          <a:xfrm>
+            <a:off x="731520" y="548640"/>
+            <a:ext cx="137160" cy="548640"/>
+          </a:xfrm>
+          <a:prstGeom prst="rect">
+            <a:avLst/>
+          </a:prstGeom>
+          <a:solidFill>
+            <a:srgbClr val="2563EB"/>
+          </a:solidFill>
+          <a:ln>
+            <a:noFill/>
+          </a:ln>
+        </p:spPr>
+        <p:style>
+          <a:lnRef idx="1">
+            <a:schemeClr val="accent1"/>
+          </a:lnRef>
+          <a:fillRef idx="3">
+            <a:schemeClr val="accent1"/>
+          </a:fillRef>
+          <a:effectRef idx="2">
+            <a:schemeClr val="accent1"/>
+          </a:effectRef>
+          <a:fontRef idx="minor">
+            <a:schemeClr val="lt1"/>
+          </a:fontRef>
+        </p:style>
+        <p:txBody>
+          <a:bodyPr rtlCol="0" anchor="ctr"/>
+          <a:lstStyle/>
+          <a:p>
+            <a:pPr algn="ctr"/>
+          </a:p>
+        </p:txBody>
+      </p:sp>
+      <p:sp>
+        <p:nvSpPr>
+          <p:cNvPr id="3" name="TextBox 2"/>
+          <p:cNvSpPr txBox="1"/>
+          <p:nvPr/>
+        </p:nvSpPr>
+        <p:spPr>
+          <a:xfrm>
+            <a:off x="1005840" y="457200"/>
+            <a:ext cx="10058400" cy="731520"/>
+          </a:xfrm>
+          <a:prstGeom prst="rect">
+            <a:avLst/>
+          </a:prstGeom>
+          <a:noFill/>
+        </p:spPr>
+        <p:txBody>
+          <a:bodyPr wrap="square" lIns="0" tIns="0" rIns="0" bIns="0">
+            <a:spAutoFit/>
+          </a:bodyPr>
+          <a:lstStyle/>
+          <a:p>
+            <a:pPr>
+              <a:defRPr sz="2600" b="1">
+                <a:solidFill>
+                  <a:srgbClr val="0F172A"/>
+                </a:solidFill>
+                <a:latin typeface="Microsoft JhengHei"/>
+              </a:defRPr>
+            </a:pPr>
+            <a:r>
+              <a:t>08  總結與未來展望</a:t>
+            </a:r>
+          </a:p>
+        </p:txBody>
+      </p:sp>
+      <p:sp>
+        <p:nvSpPr>
+          <p:cNvPr id="4" name="Rounded Rectangle 3"/>
+          <p:cNvSpPr/>
+          <p:nvPr/>
+        </p:nvSpPr>
+        <p:spPr>
+          <a:xfrm>
+            <a:off x="731520" y="1463040"/>
+            <a:ext cx="5120640" cy="4572000"/>
+          </a:xfrm>
+          <a:prstGeom prst="roundRect">
+            <a:avLst/>
+          </a:prstGeom>
+          <a:solidFill>
+            <a:srgbClr val="FFFFFF"/>
+          </a:solidFill>
+          <a:ln w="19050">
+            <a:solidFill>
+              <a:srgbClr val="10B981"/>
+            </a:solidFill>
+          </a:ln>
+        </p:spPr>
+        <p:style>
+          <a:lnRef idx="1">
+            <a:schemeClr val="accent1"/>
+          </a:lnRef>
+          <a:fillRef idx="3">
+            <a:schemeClr val="accent1"/>
+          </a:fillRef>
+          <a:effectRef idx="2">
+            <a:schemeClr val="accent1"/>
+          </a:effectRef>
+          <a:fontRef idx="minor">
+            <a:schemeClr val="lt1"/>
+          </a:fontRef>
+        </p:style>
+        <p:txBody>
+          <a:bodyPr rtlCol="0" anchor="ctr"/>
+          <a:lstStyle/>
+          <a:p>
+            <a:pPr algn="ctr"/>
+          </a:p>
+        </p:txBody>
+      </p:sp>
+      <p:sp>
+        <p:nvSpPr>
+          <p:cNvPr id="5" name="TextBox 4"/>
+          <p:cNvSpPr txBox="1"/>
+          <p:nvPr/>
+        </p:nvSpPr>
+        <p:spPr>
+          <a:xfrm>
+            <a:off x="1005840" y="1737360"/>
+            <a:ext cx="4572000" cy="4023360"/>
+          </a:xfrm>
+          <a:prstGeom prst="rect">
+            <a:avLst/>
+          </a:prstGeom>
+          <a:noFill/>
+        </p:spPr>
+        <p:txBody>
+          <a:bodyPr wrap="square" tIns="91440" bIns="91440">
+            <a:spAutoFit/>
+          </a:bodyPr>
+          <a:lstStyle/>
+          <a:p>
+            <a:pPr>
+              <a:spcAft>
+                <a:spcPts val="1000"/>
+              </a:spcAft>
+              <a:defRPr sz="2000" b="1">
+                <a:solidFill>
+                  <a:srgbClr val="0F172A"/>
+                </a:solidFill>
+                <a:latin typeface="Microsoft JhengHei"/>
+              </a:defRPr>
+            </a:pPr>
+            <a:r>
+              <a:t>🏆 系統實施成效</a:t>
+            </a:r>
+          </a:p>
+          <a:p>
+            <a:pPr>
+              <a:lnSpc>
+                <a:spcPct val="115000"/>
+              </a:lnSpc>
+              <a:spcAft>
+                <a:spcPts val="600"/>
+              </a:spcAft>
+              <a:defRPr sz="1500">
+                <a:solidFill>
+                  <a:srgbClr val="0F172A"/>
+                </a:solidFill>
+                <a:latin typeface="Microsoft JhengHei"/>
+              </a:defRPr>
+            </a:pPr>
+            <a:r>
+              <a:t>• 被動防護轉為主動防禦：跳脫傳統事後調閱監視器的模式，在違規發生的第一秒立即通報，將意外機率降至最低。</a:t>
+            </a:r>
+          </a:p>
+          <a:p>
+            <a:pPr>
+              <a:lnSpc>
+                <a:spcPct val="115000"/>
+              </a:lnSpc>
+              <a:spcAft>
+                <a:spcPts val="600"/>
+              </a:spcAft>
+              <a:defRPr sz="1500">
+                <a:solidFill>
+                  <a:srgbClr val="0F172A"/>
+                </a:solidFill>
+                <a:latin typeface="Microsoft JhengHei"/>
+              </a:defRPr>
+            </a:pPr>
+            <a:r>
+              <a:t>• 工安管理數位化：結合資料庫與 AI 分析，將冰冷的監控影像轉化為具備管理價值的工安稽核報告與影片事證庫。</a:t>
+            </a:r>
+          </a:p>
+          <a:p>
+            <a:pPr>
+              <a:lnSpc>
+                <a:spcPct val="115000"/>
+              </a:lnSpc>
+              <a:spcAft>
+                <a:spcPts val="600"/>
+              </a:spcAft>
+              <a:defRPr sz="1500">
+                <a:solidFill>
+                  <a:srgbClr val="0F172A"/>
+                </a:solidFill>
+                <a:latin typeface="Microsoft JhengHei"/>
+              </a:defRPr>
+            </a:pPr>
+            <a:r>
+              <a:t>• 顯著降低巡檢人力：全天候自動化監控，減輕安全稽核人員現場巡查負擔，提升管理效率。</a:t>
+            </a:r>
+          </a:p>
+        </p:txBody>
+      </p:sp>
+      <p:sp>
+        <p:nvSpPr>
+          <p:cNvPr id="6" name="Rounded Rectangle 5"/>
+          <p:cNvSpPr/>
+          <p:nvPr/>
+        </p:nvSpPr>
+        <p:spPr>
+          <a:xfrm>
+            <a:off x="6309360" y="1463040"/>
+            <a:ext cx="5120640" cy="4572000"/>
+          </a:xfrm>
+          <a:prstGeom prst="roundRect">
+            <a:avLst/>
+          </a:prstGeom>
+          <a:solidFill>
+            <a:srgbClr val="FFFFFF"/>
+          </a:solidFill>
+          <a:ln w="19050">
+            <a:solidFill>
+              <a:srgbClr val="2563EB"/>
+            </a:solidFill>
+          </a:ln>
+        </p:spPr>
+        <p:style>
+          <a:lnRef idx="1">
+            <a:schemeClr val="accent1"/>
+          </a:lnRef>
+          <a:fillRef idx="3">
+            <a:schemeClr val="accent1"/>
+          </a:fillRef>
+          <a:effectRef idx="2">
+            <a:schemeClr val="accent1"/>
+          </a:effectRef>
+          <a:fontRef idx="minor">
+            <a:schemeClr val="lt1"/>
+          </a:fontRef>
+        </p:style>
+        <p:txBody>
+          <a:bodyPr rtlCol="0" anchor="ctr"/>
+          <a:lstStyle/>
+          <a:p>
+            <a:pPr algn="ctr"/>
+          </a:p>
+        </p:txBody>
+      </p:sp>
+      <p:sp>
+        <p:nvSpPr>
+          <p:cNvPr id="7" name="TextBox 6"/>
+          <p:cNvSpPr txBox="1"/>
+          <p:nvPr/>
+        </p:nvSpPr>
+        <p:spPr>
+          <a:xfrm>
+            <a:off x="6583680" y="1737360"/>
+            <a:ext cx="4572000" cy="4023360"/>
+          </a:xfrm>
+          <a:prstGeom prst="rect">
+            <a:avLst/>
+          </a:prstGeom>
+          <a:noFill/>
+        </p:spPr>
+        <p:txBody>
+          <a:bodyPr wrap="square" tIns="91440" bIns="91440">
+            <a:spAutoFit/>
+          </a:bodyPr>
+          <a:lstStyle/>
+          <a:p>
+            <a:pPr>
+              <a:spcAft>
+                <a:spcPts val="1000"/>
+              </a:spcAft>
+              <a:defRPr sz="2000" b="1">
+                <a:solidFill>
+                  <a:srgbClr val="0F172A"/>
+                </a:solidFill>
+                <a:latin typeface="Microsoft JhengHei"/>
+              </a:defRPr>
+            </a:pPr>
+            <a:r>
+              <a:t>🚀 未來擴充方向</a:t>
+            </a:r>
+          </a:p>
+          <a:p>
+            <a:pPr>
+              <a:lnSpc>
+                <a:spcPct val="115000"/>
+              </a:lnSpc>
+              <a:spcAft>
+                <a:spcPts val="600"/>
+              </a:spcAft>
+              <a:defRPr sz="1500">
+                <a:solidFill>
+                  <a:srgbClr val="0F172A"/>
+                </a:solidFill>
+                <a:latin typeface="Microsoft JhengHei"/>
+              </a:defRPr>
+            </a:pPr>
+            <a:r>
+              <a:t>• 擴充更多防護具識別：未來計劃引入安全鞋、防墜安全帶、護目鏡或口罩等多種類別的 YOLO 偵測模型。</a:t>
+            </a:r>
+          </a:p>
+          <a:p>
+            <a:pPr>
+              <a:lnSpc>
+                <a:spcPct val="115000"/>
+              </a:lnSpc>
+              <a:spcAft>
+                <a:spcPts val="600"/>
+              </a:spcAft>
+              <a:defRPr sz="1500">
+                <a:solidFill>
+                  <a:srgbClr val="0F172A"/>
+                </a:solidFill>
+                <a:latin typeface="Microsoft JhengHei"/>
+              </a:defRPr>
+            </a:pPr>
+            <a:r>
+              <a:t>• 多相機與多廠區支援：支援接入多路 IP Camera，實現大規模廠區或跨廠區的同步邊緣監控與集中管理。</a:t>
+            </a:r>
+          </a:p>
+          <a:p>
+            <a:pPr>
+              <a:lnSpc>
+                <a:spcPct val="115000"/>
+              </a:lnSpc>
+              <a:spcAft>
+                <a:spcPts val="600"/>
+              </a:spcAft>
+              <a:defRPr sz="1500">
+                <a:solidFill>
+                  <a:srgbClr val="0F172A"/>
+                </a:solidFill>
+                <a:latin typeface="Microsoft JhengHei"/>
+              </a:defRPr>
+            </a:pPr>
+            <a:r>
+              <a:t>• 雙平台通報機制：除目前已實現的 Discord 通報外，未來可啟用並完善 LINE Notify 通報，滿足多元通訊需求。</a:t>
             </a:r>
           </a:p>
         </p:txBody>

</xml_diff>